<commit_message>
Add automatic Markdown companion for test cases
</commit_message>
<xml_diff>
--- a/docs/portable-testing-pipeline-ru.pptx
+++ b/docs/portable-testing-pipeline-ru.pptx
@@ -2,38 +2,38 @@
 <file path=ppt/presentation.xml><?xml version="1.0" encoding="utf-8"?>
 <p:presentation xmlns:p="http://schemas.openxmlformats.org/presentationml/2006/main" embedTrueTypeFonts="1" saveSubsetFonts="0">
   <p:sldMasterIdLst>
-    <p:sldMasterId xmlns:r="http://schemas.openxmlformats.org/officeDocument/2006/relationships" id="2147483648" r:id="R7f1038b90229445a"/>
+    <p:sldMasterId xmlns:r="http://schemas.openxmlformats.org/officeDocument/2006/relationships" id="2147483648" r:id="R3a81872d62be457a"/>
   </p:sldMasterIdLst>
   <p:notesMasterIdLst>
-    <p:notesMasterId xmlns:r="http://schemas.openxmlformats.org/officeDocument/2006/relationships" r:id="Rc88296bc844b4a3c"/>
+    <p:notesMasterId xmlns:r="http://schemas.openxmlformats.org/officeDocument/2006/relationships" r:id="Rfb5adb70775e4204"/>
   </p:notesMasterIdLst>
   <p:sldIdLst>
-    <p:sldId xmlns:r="http://schemas.openxmlformats.org/officeDocument/2006/relationships" id="256" r:id="Ra357e02f9f724a77"/>
-    <p:sldId xmlns:r="http://schemas.openxmlformats.org/officeDocument/2006/relationships" id="257" r:id="Ra8b899cd746244a9"/>
-    <p:sldId xmlns:r="http://schemas.openxmlformats.org/officeDocument/2006/relationships" id="258" r:id="Rcfe829116b2a40b9"/>
-    <p:sldId xmlns:r="http://schemas.openxmlformats.org/officeDocument/2006/relationships" id="259" r:id="Rd2be72814dd44f2b"/>
-    <p:sldId xmlns:r="http://schemas.openxmlformats.org/officeDocument/2006/relationships" id="260" r:id="Re1aaa5da33a44fa6"/>
-    <p:sldId xmlns:r="http://schemas.openxmlformats.org/officeDocument/2006/relationships" id="261" r:id="R92a7dfb96a444e3a"/>
-    <p:sldId xmlns:r="http://schemas.openxmlformats.org/officeDocument/2006/relationships" id="262" r:id="Rc557c8e4663d47c2"/>
-    <p:sldId xmlns:r="http://schemas.openxmlformats.org/officeDocument/2006/relationships" id="263" r:id="R9010abf2b99f44be"/>
-    <p:sldId xmlns:r="http://schemas.openxmlformats.org/officeDocument/2006/relationships" id="264" r:id="R3511726d0a7d474f"/>
-    <p:sldId xmlns:r="http://schemas.openxmlformats.org/officeDocument/2006/relationships" id="265" r:id="Rfddd1d306c0242c5"/>
-    <p:sldId xmlns:r="http://schemas.openxmlformats.org/officeDocument/2006/relationships" id="266" r:id="R66d0d9aec37b434d"/>
-    <p:sldId xmlns:r="http://schemas.openxmlformats.org/officeDocument/2006/relationships" id="267" r:id="R874c307db3b44081"/>
-    <p:sldId xmlns:r="http://schemas.openxmlformats.org/officeDocument/2006/relationships" id="268" r:id="Rf950efded3644750"/>
-    <p:sldId xmlns:r="http://schemas.openxmlformats.org/officeDocument/2006/relationships" id="269" r:id="Rb8cf0c3e89f04e61"/>
-    <p:sldId xmlns:r="http://schemas.openxmlformats.org/officeDocument/2006/relationships" id="270" r:id="R2f330ec4355d4b3c"/>
-    <p:sldId xmlns:r="http://schemas.openxmlformats.org/officeDocument/2006/relationships" id="271" r:id="Rbc3040ff1a0743b8"/>
+    <p:sldId xmlns:r="http://schemas.openxmlformats.org/officeDocument/2006/relationships" id="256" r:id="Rf6e7fdb1211645c2"/>
+    <p:sldId xmlns:r="http://schemas.openxmlformats.org/officeDocument/2006/relationships" id="257" r:id="R8c2c0dbf85d047d1"/>
+    <p:sldId xmlns:r="http://schemas.openxmlformats.org/officeDocument/2006/relationships" id="258" r:id="Rb0084f79172d406d"/>
+    <p:sldId xmlns:r="http://schemas.openxmlformats.org/officeDocument/2006/relationships" id="259" r:id="R0981ff09299a4d70"/>
+    <p:sldId xmlns:r="http://schemas.openxmlformats.org/officeDocument/2006/relationships" id="260" r:id="R9bdd1bbd459a4eca"/>
+    <p:sldId xmlns:r="http://schemas.openxmlformats.org/officeDocument/2006/relationships" id="261" r:id="R15e202a4aa164a50"/>
+    <p:sldId xmlns:r="http://schemas.openxmlformats.org/officeDocument/2006/relationships" id="262" r:id="Rdc3878e536344c19"/>
+    <p:sldId xmlns:r="http://schemas.openxmlformats.org/officeDocument/2006/relationships" id="263" r:id="Ree7f567a871b45dc"/>
+    <p:sldId xmlns:r="http://schemas.openxmlformats.org/officeDocument/2006/relationships" id="264" r:id="Ra9497b8251ac48aa"/>
+    <p:sldId xmlns:r="http://schemas.openxmlformats.org/officeDocument/2006/relationships" id="265" r:id="R4bfe8025273943a9"/>
+    <p:sldId xmlns:r="http://schemas.openxmlformats.org/officeDocument/2006/relationships" id="266" r:id="Ra4ab888d3e154aea"/>
+    <p:sldId xmlns:r="http://schemas.openxmlformats.org/officeDocument/2006/relationships" id="267" r:id="R18c7c9150ec5472e"/>
+    <p:sldId xmlns:r="http://schemas.openxmlformats.org/officeDocument/2006/relationships" id="268" r:id="Rb1e00d89ef0e48ab"/>
+    <p:sldId xmlns:r="http://schemas.openxmlformats.org/officeDocument/2006/relationships" id="269" r:id="Race601fe641e4a7d"/>
+    <p:sldId xmlns:r="http://schemas.openxmlformats.org/officeDocument/2006/relationships" id="270" r:id="Rd1c55bc6f241454e"/>
+    <p:sldId xmlns:r="http://schemas.openxmlformats.org/officeDocument/2006/relationships" id="271" r:id="R6a4c805ea5cf4beb"/>
   </p:sldIdLst>
   <p:sldSz cx="12192000" cy="6858000"/>
   <p:notesSz cx="6858000" cy="9144000"/>
   <p:embeddedFontLst>
     <p:embeddedFont>
       <p:font typeface="OpenAI Sans"/>
-      <p:regular xmlns:r="http://schemas.openxmlformats.org/officeDocument/2006/relationships" r:id="R58c256ae08124e29"/>
-      <p:bold xmlns:r="http://schemas.openxmlformats.org/officeDocument/2006/relationships" r:id="Red2e5af4609245ca"/>
-      <p:italic xmlns:r="http://schemas.openxmlformats.org/officeDocument/2006/relationships" r:id="R514cde7aef8646fc"/>
-      <p:boldItalic xmlns:r="http://schemas.openxmlformats.org/officeDocument/2006/relationships" r:id="Rfd85251e23d0403d"/>
+      <p:regular xmlns:r="http://schemas.openxmlformats.org/officeDocument/2006/relationships" r:id="R6113796815604135"/>
+      <p:bold xmlns:r="http://schemas.openxmlformats.org/officeDocument/2006/relationships" r:id="R6a1f0ec12bcc4765"/>
+      <p:italic xmlns:r="http://schemas.openxmlformats.org/officeDocument/2006/relationships" r:id="R8075cb0b42444ada"/>
+      <p:boldItalic xmlns:r="http://schemas.openxmlformats.org/officeDocument/2006/relationships" r:id="R12369813bced4422"/>
     </p:embeddedFont>
   </p:embeddedFontLst>
 </p:presentation>
@@ -1160,7 +1160,7 @@
               <a:buNone/>
             </a:pPr>
             <a:r>
-              <a:t>Начинаем с задачи команды. Требование нужно превратить в проверяемый сценарий, затем решить, можно ли его автоматизировать, написать тест и объяснить результат. При ручном переходе между этими шагами легко потерять условие, придумать лишнюю проверку или принять зелёный отчёт без связи с задачей. Пайплайн делает эти переходы явными. Есть два профиля. cases-only-v1 заканчивается проверенными тест-кейсами: код проекта не запускается. Это самостоятельный результат для ручного тестирования и обсуждения требований. local-pilot-v1 продолжает путь до автотестов и запуска. Для него нужно разрешение на выполнение в выбранном проекте. HTML удобен человеку, JSON хранит смысл сценариев, CSV служит выгрузкой. Команда выбирает объём работы под задачу. Качество исходных требований по-прежнему важно: если поведение не определено, модель не должна молча придумывать продуктовую спецификацию.</a:t>
+              <a:t>Начинаем с задачи команды. Требование нужно превратить в проверяемый сценарий, затем решить, можно ли его автоматизировать, написать тест и объяснить результат. При ручном переходе между этими шагами легко потерять условие, придумать лишнюю проверку или принять зелёный отчёт без связи с задачей. Пайплайн делает эти переходы явными. Есть два профиля. cases-only-v1 заканчивается проверенными тест-кейсами: код проекта не запускается. Это самостоятельный результат для ручного тестирования и обсуждения требований. local-pilot-v1 продолжает путь до автотестов и запуска. Для него нужно разрешение на выполнение в выбранном проекте. HTML и Markdown удобны человеку, JSON хранит смысл сценариев, CSV служит выгрузкой. Команда выбирает объём работы под задачу. Качество исходных требований по-прежнему важно: если поведение не определено, модель не должна молча придумывать продуктовую спецификацию.</a:t>
             </a:r>
             <a:endParaRPr/>
           </a:p>
@@ -3754,14 +3754,14 @@
   </p:cSld>
   <p:clrMap bg1="dk1" tx1="lt1" bg2="dk2" tx2="lt2" accent1="accent1" accent2="accent2" accent3="accent3" accent4="accent4" accent5="accent5" accent6="accent6" hlink="hlink" folHlink="folHlink"/>
   <p:sldLayoutIdLst>
-    <p:sldLayoutId xmlns:r="http://schemas.openxmlformats.org/officeDocument/2006/relationships" id="2147483649" r:id="R58a33aec0dc7464d"/>
-    <p:sldLayoutId xmlns:r="http://schemas.openxmlformats.org/officeDocument/2006/relationships" id="2147483650" r:id="R8c81734fea6b4590"/>
-    <p:sldLayoutId xmlns:r="http://schemas.openxmlformats.org/officeDocument/2006/relationships" id="2147483651" r:id="R6432211bd9da43f0"/>
-    <p:sldLayoutId xmlns:r="http://schemas.openxmlformats.org/officeDocument/2006/relationships" id="2147483652" r:id="R5cfc88b3e1b24eec"/>
-    <p:sldLayoutId xmlns:r="http://schemas.openxmlformats.org/officeDocument/2006/relationships" id="2147483653" r:id="Re0088049b4d64c6b"/>
-    <p:sldLayoutId xmlns:r="http://schemas.openxmlformats.org/officeDocument/2006/relationships" id="2147483654" r:id="Re0aa97023a3947d3"/>
-    <p:sldLayoutId xmlns:r="http://schemas.openxmlformats.org/officeDocument/2006/relationships" id="2147483655" r:id="R516478b6065a4091"/>
-    <p:sldLayoutId xmlns:r="http://schemas.openxmlformats.org/officeDocument/2006/relationships" id="2147483656" r:id="R7dc18c29afbb49bf"/>
+    <p:sldLayoutId xmlns:r="http://schemas.openxmlformats.org/officeDocument/2006/relationships" id="2147483649" r:id="Rf8a062f818e14347"/>
+    <p:sldLayoutId xmlns:r="http://schemas.openxmlformats.org/officeDocument/2006/relationships" id="2147483650" r:id="R80bc66abc26947aa"/>
+    <p:sldLayoutId xmlns:r="http://schemas.openxmlformats.org/officeDocument/2006/relationships" id="2147483651" r:id="Rae981b120ce34698"/>
+    <p:sldLayoutId xmlns:r="http://schemas.openxmlformats.org/officeDocument/2006/relationships" id="2147483652" r:id="R603cfd9d53a24262"/>
+    <p:sldLayoutId xmlns:r="http://schemas.openxmlformats.org/officeDocument/2006/relationships" id="2147483653" r:id="Re29b84d682b64640"/>
+    <p:sldLayoutId xmlns:r="http://schemas.openxmlformats.org/officeDocument/2006/relationships" id="2147483654" r:id="R52cbee431b0349d0"/>
+    <p:sldLayoutId xmlns:r="http://schemas.openxmlformats.org/officeDocument/2006/relationships" id="2147483655" r:id="R461e1cec86844608"/>
+    <p:sldLayoutId xmlns:r="http://schemas.openxmlformats.org/officeDocument/2006/relationships" id="2147483656" r:id="R15e73d7f0c754102"/>
   </p:sldLayoutIdLst>
   <p:hf hdr="0" dt="0"/>
   <p:txStyles>
@@ -4698,7 +4698,7 @@
           <p:nvPr/>
         </p:nvPicPr>
         <p:blipFill>
-          <a:blip xmlns:r="http://schemas.openxmlformats.org/officeDocument/2006/relationships" xmlns:a="http://schemas.openxmlformats.org/drawingml/2006/main" r:embed="R7988e69daa86446c"/>
+          <a:blip xmlns:r="http://schemas.openxmlformats.org/officeDocument/2006/relationships" xmlns:a="http://schemas.openxmlformats.org/drawingml/2006/main" r:embed="Rfd02896dfe384723"/>
           <a:srcRect xmlns:a="http://schemas.openxmlformats.org/drawingml/2006/main" l="8269" t="0" r="8269" b="0"/>
           <a:stretch xmlns:a="http://schemas.openxmlformats.org/drawingml/2006/main"/>
         </p:blipFill>
@@ -13364,7 +13364,7 @@
                 <a:ea typeface="Helvetica Neue"/>
                 <a:cs typeface="Helvetica Neue"/>
               </a:rPr>
-              <a:t>Отдельное ревью. JSON, HTML и CSV.</a:t>
+              <a:t>Отдельное ревью. JSON, HTML, Markdown и CSV.</a:t>
             </a:r>
           </a:p>
         </p:txBody>

</xml_diff>